<commit_message>
Redesign W0 templates as a cuttable badge sheet
6 identical 58mm circles (dashed border = cut line) for the same
Workshop 0 logo, pasted/copied into each, plus one shared description
field instead of per-circle prompts.

Co-Authored-By: Claude Sonnet 5 <noreply@anthropic.com>
</commit_message>
<xml_diff>
--- a/W0/team-logo-template.pptx
+++ b/W0/team-logo-template.pptx
@@ -901,7 +901,7 @@
                 <a:ea typeface="Cambria" pitchFamily="34" charset="-122"/>
                 <a:cs typeface="Cambria" pitchFamily="34" charset="-120"/>
               </a:rPr>
-              <a:t>Team Logo Concepts</a:t>
+              <a:t>Team Badge Sheet</a:t>
             </a:r>
             <a:endParaRPr lang="en-US" sz="2600" dirty="0"/>
           </a:p>
@@ -916,7 +916,7 @@
         <p:spPr>
           <a:xfrm>
             <a:off x="457200" y="841248"/>
-            <a:ext cx="6647688" cy="457200"/>
+            <a:ext cx="6647688" cy="502920"/>
           </a:xfrm>
           <a:prstGeom prst="rect">
             <a:avLst/>
@@ -940,7 +940,7 @@
                 <a:ea typeface="Calibri" pitchFamily="34" charset="-122"/>
                 <a:cs typeface="Calibri" pitchFamily="34" charset="-120"/>
               </a:rPr>
-              <a:t>Sketch or paste 6 logo concepts, one per circle (each 58 mm diameter). Underneath each, briefly note the inspiration and how it represents your app.</a:t>
+              <a:t>Paste the logo you designed in Workshop 0 into one circle below, then copy it into the other 5 (each is 58 mm diameter — a standard badge size). Print and cut along the dashed lines to make your team's badges.</a:t>
             </a:r>
             <a:endParaRPr lang="en-US" sz="1200" dirty="0"/>
           </a:p>
@@ -954,7 +954,7 @@
         </p:nvSpPr>
         <p:spPr>
           <a:xfrm>
-            <a:off x="457200" y="1298448"/>
+            <a:off x="457200" y="1417320"/>
             <a:ext cx="1051560" cy="274320"/>
           </a:xfrm>
           <a:prstGeom prst="rect">
@@ -993,7 +993,7 @@
         </p:nvSpPr>
         <p:spPr>
           <a:xfrm>
-            <a:off x="1554480" y="1536192"/>
+            <a:off x="1554480" y="1655064"/>
             <a:ext cx="5550408" cy="0"/>
           </a:xfrm>
           <a:prstGeom prst="line">
@@ -1016,7 +1016,7 @@
         </p:nvSpPr>
         <p:spPr>
           <a:xfrm>
-            <a:off x="475428" y="1874520"/>
+            <a:off x="475428" y="2011680"/>
             <a:ext cx="2088000" cy="2088000"/>
           </a:xfrm>
           <a:prstGeom prst="ellipse">
@@ -1041,8 +1041,8 @@
         </p:nvSpPr>
         <p:spPr>
           <a:xfrm>
-            <a:off x="457200" y="4163688"/>
-            <a:ext cx="2124456" cy="292608"/>
+            <a:off x="475428" y="2011680"/>
+            <a:ext cx="2088000" cy="2088000"/>
           </a:xfrm>
           <a:prstGeom prst="rect">
             <a:avLst/>
@@ -1051,14 +1051,373 @@
           <a:ln/>
         </p:spPr>
         <p:txBody>
-          <a:bodyPr wrap="square" lIns="0" tIns="0" rIns="0" bIns="0" rtlCol="0" anchor="t"/>
+          <a:bodyPr wrap="square" lIns="0" tIns="0" rIns="0" bIns="0" rtlCol="0" anchor="ctr"/>
+          <a:lstStyle/>
+          <a:p>
+            <a:pPr algn="ctr" indent="0" marL="0">
+              <a:buNone/>
+            </a:pPr>
+            <a:r>
+              <a:rPr lang="en-US" sz="1000" i="1" dirty="0">
+                <a:solidFill>
+                  <a:srgbClr val="C7CDD4"/>
+                </a:solidFill>
+                <a:latin typeface="Calibri" pitchFamily="34" charset="0"/>
+                <a:ea typeface="Calibri" pitchFamily="34" charset="-122"/>
+                <a:cs typeface="Calibri" pitchFamily="34" charset="-120"/>
+              </a:rPr>
+              <a:t>paste logo here</a:t>
+            </a:r>
+            <a:endParaRPr lang="en-US" sz="1000" dirty="0"/>
+          </a:p>
+        </p:txBody>
+      </p:sp>
+      <p:sp>
+        <p:nvSpPr>
+          <p:cNvPr id="8" name="Shape 6"/>
+          <p:cNvSpPr/>
+          <p:nvPr/>
+        </p:nvSpPr>
+        <p:spPr>
+          <a:xfrm>
+            <a:off x="2737044" y="2011680"/>
+            <a:ext cx="2088000" cy="2088000"/>
+          </a:xfrm>
+          <a:prstGeom prst="ellipse">
+            <a:avLst/>
+          </a:prstGeom>
+          <a:solidFill>
+            <a:srgbClr val="FFFFFF"/>
+          </a:solidFill>
+          <a:ln w="15875">
+            <a:solidFill>
+              <a:srgbClr val="9AA4B0"/>
+            </a:solidFill>
+            <a:prstDash val="dash"/>
+          </a:ln>
+        </p:spPr>
+      </p:sp>
+      <p:sp>
+        <p:nvSpPr>
+          <p:cNvPr id="9" name="Text 7"/>
+          <p:cNvSpPr txBox="1"/>
+          <p:nvPr/>
+        </p:nvSpPr>
+        <p:spPr>
+          <a:xfrm>
+            <a:off x="2737044" y="2011680"/>
+            <a:ext cx="2088000" cy="2088000"/>
+          </a:xfrm>
+          <a:prstGeom prst="rect">
+            <a:avLst/>
+          </a:prstGeom>
+          <a:noFill/>
+          <a:ln/>
+        </p:spPr>
+        <p:txBody>
+          <a:bodyPr wrap="square" lIns="0" tIns="0" rIns="0" bIns="0" rtlCol="0" anchor="ctr"/>
+          <a:lstStyle/>
+          <a:p>
+            <a:pPr algn="ctr" indent="0" marL="0">
+              <a:buNone/>
+            </a:pPr>
+            <a:r>
+              <a:rPr lang="en-US" sz="1000" i="1" dirty="0">
+                <a:solidFill>
+                  <a:srgbClr val="C7CDD4"/>
+                </a:solidFill>
+                <a:latin typeface="Calibri" pitchFamily="34" charset="0"/>
+                <a:ea typeface="Calibri" pitchFamily="34" charset="-122"/>
+                <a:cs typeface="Calibri" pitchFamily="34" charset="-120"/>
+              </a:rPr>
+              <a:t>paste logo here</a:t>
+            </a:r>
+            <a:endParaRPr lang="en-US" sz="1000" dirty="0"/>
+          </a:p>
+        </p:txBody>
+      </p:sp>
+      <p:sp>
+        <p:nvSpPr>
+          <p:cNvPr id="10" name="Shape 8"/>
+          <p:cNvSpPr/>
+          <p:nvPr/>
+        </p:nvSpPr>
+        <p:spPr>
+          <a:xfrm>
+            <a:off x="4998660" y="2011680"/>
+            <a:ext cx="2088000" cy="2088000"/>
+          </a:xfrm>
+          <a:prstGeom prst="ellipse">
+            <a:avLst/>
+          </a:prstGeom>
+          <a:solidFill>
+            <a:srgbClr val="FFFFFF"/>
+          </a:solidFill>
+          <a:ln w="15875">
+            <a:solidFill>
+              <a:srgbClr val="9AA4B0"/>
+            </a:solidFill>
+            <a:prstDash val="dash"/>
+          </a:ln>
+        </p:spPr>
+      </p:sp>
+      <p:sp>
+        <p:nvSpPr>
+          <p:cNvPr id="11" name="Text 9"/>
+          <p:cNvSpPr txBox="1"/>
+          <p:nvPr/>
+        </p:nvSpPr>
+        <p:spPr>
+          <a:xfrm>
+            <a:off x="4998660" y="2011680"/>
+            <a:ext cx="2088000" cy="2088000"/>
+          </a:xfrm>
+          <a:prstGeom prst="rect">
+            <a:avLst/>
+          </a:prstGeom>
+          <a:noFill/>
+          <a:ln/>
+        </p:spPr>
+        <p:txBody>
+          <a:bodyPr wrap="square" lIns="0" tIns="0" rIns="0" bIns="0" rtlCol="0" anchor="ctr"/>
+          <a:lstStyle/>
+          <a:p>
+            <a:pPr algn="ctr" indent="0" marL="0">
+              <a:buNone/>
+            </a:pPr>
+            <a:r>
+              <a:rPr lang="en-US" sz="1000" i="1" dirty="0">
+                <a:solidFill>
+                  <a:srgbClr val="C7CDD4"/>
+                </a:solidFill>
+                <a:latin typeface="Calibri" pitchFamily="34" charset="0"/>
+                <a:ea typeface="Calibri" pitchFamily="34" charset="-122"/>
+                <a:cs typeface="Calibri" pitchFamily="34" charset="-120"/>
+              </a:rPr>
+              <a:t>paste logo here</a:t>
+            </a:r>
+            <a:endParaRPr lang="en-US" sz="1000" dirty="0"/>
+          </a:p>
+        </p:txBody>
+      </p:sp>
+      <p:sp>
+        <p:nvSpPr>
+          <p:cNvPr id="12" name="Shape 10"/>
+          <p:cNvSpPr/>
+          <p:nvPr/>
+        </p:nvSpPr>
+        <p:spPr>
+          <a:xfrm>
+            <a:off x="475428" y="4328280"/>
+            <a:ext cx="2088000" cy="2088000"/>
+          </a:xfrm>
+          <a:prstGeom prst="ellipse">
+            <a:avLst/>
+          </a:prstGeom>
+          <a:solidFill>
+            <a:srgbClr val="FFFFFF"/>
+          </a:solidFill>
+          <a:ln w="15875">
+            <a:solidFill>
+              <a:srgbClr val="9AA4B0"/>
+            </a:solidFill>
+            <a:prstDash val="dash"/>
+          </a:ln>
+        </p:spPr>
+      </p:sp>
+      <p:sp>
+        <p:nvSpPr>
+          <p:cNvPr id="13" name="Text 11"/>
+          <p:cNvSpPr txBox="1"/>
+          <p:nvPr/>
+        </p:nvSpPr>
+        <p:spPr>
+          <a:xfrm>
+            <a:off x="475428" y="4328280"/>
+            <a:ext cx="2088000" cy="2088000"/>
+          </a:xfrm>
+          <a:prstGeom prst="rect">
+            <a:avLst/>
+          </a:prstGeom>
+          <a:noFill/>
+          <a:ln/>
+        </p:spPr>
+        <p:txBody>
+          <a:bodyPr wrap="square" lIns="0" tIns="0" rIns="0" bIns="0" rtlCol="0" anchor="ctr"/>
+          <a:lstStyle/>
+          <a:p>
+            <a:pPr algn="ctr" indent="0" marL="0">
+              <a:buNone/>
+            </a:pPr>
+            <a:r>
+              <a:rPr lang="en-US" sz="1000" i="1" dirty="0">
+                <a:solidFill>
+                  <a:srgbClr val="C7CDD4"/>
+                </a:solidFill>
+                <a:latin typeface="Calibri" pitchFamily="34" charset="0"/>
+                <a:ea typeface="Calibri" pitchFamily="34" charset="-122"/>
+                <a:cs typeface="Calibri" pitchFamily="34" charset="-120"/>
+              </a:rPr>
+              <a:t>paste logo here</a:t>
+            </a:r>
+            <a:endParaRPr lang="en-US" sz="1000" dirty="0"/>
+          </a:p>
+        </p:txBody>
+      </p:sp>
+      <p:sp>
+        <p:nvSpPr>
+          <p:cNvPr id="14" name="Shape 12"/>
+          <p:cNvSpPr/>
+          <p:nvPr/>
+        </p:nvSpPr>
+        <p:spPr>
+          <a:xfrm>
+            <a:off x="2737044" y="4328280"/>
+            <a:ext cx="2088000" cy="2088000"/>
+          </a:xfrm>
+          <a:prstGeom prst="ellipse">
+            <a:avLst/>
+          </a:prstGeom>
+          <a:solidFill>
+            <a:srgbClr val="FFFFFF"/>
+          </a:solidFill>
+          <a:ln w="15875">
+            <a:solidFill>
+              <a:srgbClr val="9AA4B0"/>
+            </a:solidFill>
+            <a:prstDash val="dash"/>
+          </a:ln>
+        </p:spPr>
+      </p:sp>
+      <p:sp>
+        <p:nvSpPr>
+          <p:cNvPr id="15" name="Text 13"/>
+          <p:cNvSpPr txBox="1"/>
+          <p:nvPr/>
+        </p:nvSpPr>
+        <p:spPr>
+          <a:xfrm>
+            <a:off x="2737044" y="4328280"/>
+            <a:ext cx="2088000" cy="2088000"/>
+          </a:xfrm>
+          <a:prstGeom prst="rect">
+            <a:avLst/>
+          </a:prstGeom>
+          <a:noFill/>
+          <a:ln/>
+        </p:spPr>
+        <p:txBody>
+          <a:bodyPr wrap="square" lIns="0" tIns="0" rIns="0" bIns="0" rtlCol="0" anchor="ctr"/>
+          <a:lstStyle/>
+          <a:p>
+            <a:pPr algn="ctr" indent="0" marL="0">
+              <a:buNone/>
+            </a:pPr>
+            <a:r>
+              <a:rPr lang="en-US" sz="1000" i="1" dirty="0">
+                <a:solidFill>
+                  <a:srgbClr val="C7CDD4"/>
+                </a:solidFill>
+                <a:latin typeface="Calibri" pitchFamily="34" charset="0"/>
+                <a:ea typeface="Calibri" pitchFamily="34" charset="-122"/>
+                <a:cs typeface="Calibri" pitchFamily="34" charset="-120"/>
+              </a:rPr>
+              <a:t>paste logo here</a:t>
+            </a:r>
+            <a:endParaRPr lang="en-US" sz="1000" dirty="0"/>
+          </a:p>
+        </p:txBody>
+      </p:sp>
+      <p:sp>
+        <p:nvSpPr>
+          <p:cNvPr id="16" name="Shape 14"/>
+          <p:cNvSpPr/>
+          <p:nvPr/>
+        </p:nvSpPr>
+        <p:spPr>
+          <a:xfrm>
+            <a:off x="4998660" y="4328280"/>
+            <a:ext cx="2088000" cy="2088000"/>
+          </a:xfrm>
+          <a:prstGeom prst="ellipse">
+            <a:avLst/>
+          </a:prstGeom>
+          <a:solidFill>
+            <a:srgbClr val="FFFFFF"/>
+          </a:solidFill>
+          <a:ln w="15875">
+            <a:solidFill>
+              <a:srgbClr val="9AA4B0"/>
+            </a:solidFill>
+            <a:prstDash val="dash"/>
+          </a:ln>
+        </p:spPr>
+      </p:sp>
+      <p:sp>
+        <p:nvSpPr>
+          <p:cNvPr id="17" name="Text 15"/>
+          <p:cNvSpPr txBox="1"/>
+          <p:nvPr/>
+        </p:nvSpPr>
+        <p:spPr>
+          <a:xfrm>
+            <a:off x="4998660" y="4328280"/>
+            <a:ext cx="2088000" cy="2088000"/>
+          </a:xfrm>
+          <a:prstGeom prst="rect">
+            <a:avLst/>
+          </a:prstGeom>
+          <a:noFill/>
+          <a:ln/>
+        </p:spPr>
+        <p:txBody>
+          <a:bodyPr wrap="square" lIns="0" tIns="0" rIns="0" bIns="0" rtlCol="0" anchor="ctr"/>
+          <a:lstStyle/>
+          <a:p>
+            <a:pPr algn="ctr" indent="0" marL="0">
+              <a:buNone/>
+            </a:pPr>
+            <a:r>
+              <a:rPr lang="en-US" sz="1000" i="1" dirty="0">
+                <a:solidFill>
+                  <a:srgbClr val="C7CDD4"/>
+                </a:solidFill>
+                <a:latin typeface="Calibri" pitchFamily="34" charset="0"/>
+                <a:ea typeface="Calibri" pitchFamily="34" charset="-122"/>
+                <a:cs typeface="Calibri" pitchFamily="34" charset="-120"/>
+              </a:rPr>
+              <a:t>paste logo here</a:t>
+            </a:r>
+            <a:endParaRPr lang="en-US" sz="1000" dirty="0"/>
+          </a:p>
+        </p:txBody>
+      </p:sp>
+      <p:sp>
+        <p:nvSpPr>
+          <p:cNvPr id="18" name="Text 16"/>
+          <p:cNvSpPr txBox="1"/>
+          <p:nvPr/>
+        </p:nvSpPr>
+        <p:spPr>
+          <a:xfrm>
+            <a:off x="457200" y="6964920"/>
+            <a:ext cx="6647688" cy="274320"/>
+          </a:xfrm>
+          <a:prstGeom prst="rect">
+            <a:avLst/>
+          </a:prstGeom>
+          <a:noFill/>
+          <a:ln/>
+        </p:spPr>
+        <p:txBody>
+          <a:bodyPr wrap="square" lIns="0" tIns="0" rIns="0" bIns="0" rtlCol="0" anchor="ctr"/>
           <a:lstStyle/>
           <a:p>
             <a:pPr indent="0" marL="0">
               <a:buNone/>
             </a:pPr>
             <a:r>
-              <a:rPr lang="en-US" sz="1000" b="1" dirty="0">
+              <a:rPr lang="en-US" sz="1300" b="1" dirty="0">
                 <a:solidFill>
                   <a:srgbClr val="1E2761"/>
                 </a:solidFill>
@@ -1066,22 +1425,22 @@
                 <a:ea typeface="Calibri" pitchFamily="34" charset="-122"/>
                 <a:cs typeface="Calibri" pitchFamily="34" charset="-120"/>
               </a:rPr>
-              <a:t>Inspiration / how you came up with it:</a:t>
+              <a:t>Inspiration / how you came up with it, and how it represents your app:</a:t>
             </a:r>
-            <a:endParaRPr lang="en-US" sz="1000" dirty="0"/>
+            <a:endParaRPr lang="en-US" sz="1300" dirty="0"/>
           </a:p>
         </p:txBody>
       </p:sp>
       <p:sp>
         <p:nvSpPr>
-          <p:cNvPr id="8" name="Shape 6"/>
+          <p:cNvPr id="19" name="Shape 17"/>
           <p:cNvSpPr/>
           <p:nvPr/>
         </p:nvSpPr>
         <p:spPr>
           <a:xfrm>
-            <a:off x="457200" y="4547736"/>
-            <a:ext cx="2124456" cy="0"/>
+            <a:off x="457200" y="7422120"/>
+            <a:ext cx="6647688" cy="0"/>
           </a:xfrm>
           <a:prstGeom prst="line">
             <a:avLst/>
@@ -1097,14 +1456,14 @@
       </p:sp>
       <p:sp>
         <p:nvSpPr>
-          <p:cNvPr id="9" name="Shape 7"/>
+          <p:cNvPr id="20" name="Shape 18"/>
           <p:cNvSpPr/>
           <p:nvPr/>
         </p:nvSpPr>
         <p:spPr>
           <a:xfrm>
-            <a:off x="457200" y="4803768"/>
-            <a:ext cx="2124456" cy="0"/>
+            <a:off x="457200" y="7742160"/>
+            <a:ext cx="6647688" cy="0"/>
           </a:xfrm>
           <a:prstGeom prst="line">
             <a:avLst/>
@@ -1120,53 +1479,14 @@
       </p:sp>
       <p:sp>
         <p:nvSpPr>
-          <p:cNvPr id="10" name="Text 8"/>
-          <p:cNvSpPr txBox="1"/>
-          <p:nvPr/>
-        </p:nvSpPr>
-        <p:spPr>
-          <a:xfrm>
-            <a:off x="457200" y="5004936"/>
-            <a:ext cx="2124456" cy="292608"/>
-          </a:xfrm>
-          <a:prstGeom prst="rect">
-            <a:avLst/>
-          </a:prstGeom>
-          <a:noFill/>
-          <a:ln/>
-        </p:spPr>
-        <p:txBody>
-          <a:bodyPr wrap="square" lIns="0" tIns="0" rIns="0" bIns="0" rtlCol="0" anchor="t"/>
-          <a:lstStyle/>
-          <a:p>
-            <a:pPr indent="0" marL="0">
-              <a:buNone/>
-            </a:pPr>
-            <a:r>
-              <a:rPr lang="en-US" sz="1000" b="1" dirty="0">
-                <a:solidFill>
-                  <a:srgbClr val="1E2761"/>
-                </a:solidFill>
-                <a:latin typeface="Calibri" pitchFamily="34" charset="0"/>
-                <a:ea typeface="Calibri" pitchFamily="34" charset="-122"/>
-                <a:cs typeface="Calibri" pitchFamily="34" charset="-120"/>
-              </a:rPr>
-              <a:t>How it represents your app:</a:t>
-            </a:r>
-            <a:endParaRPr lang="en-US" sz="1000" dirty="0"/>
-          </a:p>
-        </p:txBody>
-      </p:sp>
-      <p:sp>
-        <p:nvSpPr>
-          <p:cNvPr id="11" name="Shape 9"/>
+          <p:cNvPr id="21" name="Shape 19"/>
           <p:cNvSpPr/>
           <p:nvPr/>
         </p:nvSpPr>
         <p:spPr>
           <a:xfrm>
-            <a:off x="457200" y="5388984"/>
-            <a:ext cx="2124456" cy="0"/>
+            <a:off x="457200" y="8062200"/>
+            <a:ext cx="6647688" cy="0"/>
           </a:xfrm>
           <a:prstGeom prst="line">
             <a:avLst/>
@@ -1182,14 +1502,14 @@
       </p:sp>
       <p:sp>
         <p:nvSpPr>
-          <p:cNvPr id="12" name="Shape 10"/>
+          <p:cNvPr id="22" name="Shape 20"/>
           <p:cNvSpPr/>
           <p:nvPr/>
         </p:nvSpPr>
         <p:spPr>
           <a:xfrm>
-            <a:off x="457200" y="5645016"/>
-            <a:ext cx="2124456" cy="0"/>
+            <a:off x="457200" y="8382240"/>
+            <a:ext cx="6647688" cy="0"/>
           </a:xfrm>
           <a:prstGeom prst="line">
             <a:avLst/>
@@ -1205,966 +1525,14 @@
       </p:sp>
       <p:sp>
         <p:nvSpPr>
-          <p:cNvPr id="13" name="Shape 11"/>
-          <p:cNvSpPr/>
-          <p:nvPr/>
-        </p:nvSpPr>
-        <p:spPr>
-          <a:xfrm>
-            <a:off x="2737044" y="1874520"/>
-            <a:ext cx="2088000" cy="2088000"/>
-          </a:xfrm>
-          <a:prstGeom prst="ellipse">
-            <a:avLst/>
-          </a:prstGeom>
-          <a:solidFill>
-            <a:srgbClr val="FFFFFF"/>
-          </a:solidFill>
-          <a:ln w="15875">
-            <a:solidFill>
-              <a:srgbClr val="9AA4B0"/>
-            </a:solidFill>
-            <a:prstDash val="dash"/>
-          </a:ln>
-        </p:spPr>
-      </p:sp>
-      <p:sp>
-        <p:nvSpPr>
-          <p:cNvPr id="14" name="Text 12"/>
-          <p:cNvSpPr txBox="1"/>
-          <p:nvPr/>
-        </p:nvSpPr>
-        <p:spPr>
-          <a:xfrm>
-            <a:off x="2718816" y="4163688"/>
-            <a:ext cx="2124456" cy="292608"/>
-          </a:xfrm>
-          <a:prstGeom prst="rect">
-            <a:avLst/>
-          </a:prstGeom>
-          <a:noFill/>
-          <a:ln/>
-        </p:spPr>
-        <p:txBody>
-          <a:bodyPr wrap="square" lIns="0" tIns="0" rIns="0" bIns="0" rtlCol="0" anchor="t"/>
-          <a:lstStyle/>
-          <a:p>
-            <a:pPr indent="0" marL="0">
-              <a:buNone/>
-            </a:pPr>
-            <a:r>
-              <a:rPr lang="en-US" sz="1000" b="1" dirty="0">
-                <a:solidFill>
-                  <a:srgbClr val="1E2761"/>
-                </a:solidFill>
-                <a:latin typeface="Calibri" pitchFamily="34" charset="0"/>
-                <a:ea typeface="Calibri" pitchFamily="34" charset="-122"/>
-                <a:cs typeface="Calibri" pitchFamily="34" charset="-120"/>
-              </a:rPr>
-              <a:t>Inspiration / how you came up with it:</a:t>
-            </a:r>
-            <a:endParaRPr lang="en-US" sz="1000" dirty="0"/>
-          </a:p>
-        </p:txBody>
-      </p:sp>
-      <p:sp>
-        <p:nvSpPr>
-          <p:cNvPr id="15" name="Shape 13"/>
-          <p:cNvSpPr/>
-          <p:nvPr/>
-        </p:nvSpPr>
-        <p:spPr>
-          <a:xfrm>
-            <a:off x="2718816" y="4547736"/>
-            <a:ext cx="2124456" cy="0"/>
-          </a:xfrm>
-          <a:prstGeom prst="line">
-            <a:avLst/>
-          </a:prstGeom>
-          <a:noFill/>
-          <a:ln w="9525">
-            <a:solidFill>
-              <a:srgbClr val="9AA4B0"/>
-            </a:solidFill>
-            <a:prstDash val="solid"/>
-          </a:ln>
-        </p:spPr>
-      </p:sp>
-      <p:sp>
-        <p:nvSpPr>
-          <p:cNvPr id="16" name="Shape 14"/>
-          <p:cNvSpPr/>
-          <p:nvPr/>
-        </p:nvSpPr>
-        <p:spPr>
-          <a:xfrm>
-            <a:off x="2718816" y="4803768"/>
-            <a:ext cx="2124456" cy="0"/>
-          </a:xfrm>
-          <a:prstGeom prst="line">
-            <a:avLst/>
-          </a:prstGeom>
-          <a:noFill/>
-          <a:ln w="9525">
-            <a:solidFill>
-              <a:srgbClr val="9AA4B0"/>
-            </a:solidFill>
-            <a:prstDash val="solid"/>
-          </a:ln>
-        </p:spPr>
-      </p:sp>
-      <p:sp>
-        <p:nvSpPr>
-          <p:cNvPr id="17" name="Text 15"/>
-          <p:cNvSpPr txBox="1"/>
-          <p:nvPr/>
-        </p:nvSpPr>
-        <p:spPr>
-          <a:xfrm>
-            <a:off x="2718816" y="5004936"/>
-            <a:ext cx="2124456" cy="292608"/>
-          </a:xfrm>
-          <a:prstGeom prst="rect">
-            <a:avLst/>
-          </a:prstGeom>
-          <a:noFill/>
-          <a:ln/>
-        </p:spPr>
-        <p:txBody>
-          <a:bodyPr wrap="square" lIns="0" tIns="0" rIns="0" bIns="0" rtlCol="0" anchor="t"/>
-          <a:lstStyle/>
-          <a:p>
-            <a:pPr indent="0" marL="0">
-              <a:buNone/>
-            </a:pPr>
-            <a:r>
-              <a:rPr lang="en-US" sz="1000" b="1" dirty="0">
-                <a:solidFill>
-                  <a:srgbClr val="1E2761"/>
-                </a:solidFill>
-                <a:latin typeface="Calibri" pitchFamily="34" charset="0"/>
-                <a:ea typeface="Calibri" pitchFamily="34" charset="-122"/>
-                <a:cs typeface="Calibri" pitchFamily="34" charset="-120"/>
-              </a:rPr>
-              <a:t>How it represents your app:</a:t>
-            </a:r>
-            <a:endParaRPr lang="en-US" sz="1000" dirty="0"/>
-          </a:p>
-        </p:txBody>
-      </p:sp>
-      <p:sp>
-        <p:nvSpPr>
-          <p:cNvPr id="18" name="Shape 16"/>
-          <p:cNvSpPr/>
-          <p:nvPr/>
-        </p:nvSpPr>
-        <p:spPr>
-          <a:xfrm>
-            <a:off x="2718816" y="5388984"/>
-            <a:ext cx="2124456" cy="0"/>
-          </a:xfrm>
-          <a:prstGeom prst="line">
-            <a:avLst/>
-          </a:prstGeom>
-          <a:noFill/>
-          <a:ln w="9525">
-            <a:solidFill>
-              <a:srgbClr val="9AA4B0"/>
-            </a:solidFill>
-            <a:prstDash val="solid"/>
-          </a:ln>
-        </p:spPr>
-      </p:sp>
-      <p:sp>
-        <p:nvSpPr>
-          <p:cNvPr id="19" name="Shape 17"/>
-          <p:cNvSpPr/>
-          <p:nvPr/>
-        </p:nvSpPr>
-        <p:spPr>
-          <a:xfrm>
-            <a:off x="2718816" y="5645016"/>
-            <a:ext cx="2124456" cy="0"/>
-          </a:xfrm>
-          <a:prstGeom prst="line">
-            <a:avLst/>
-          </a:prstGeom>
-          <a:noFill/>
-          <a:ln w="9525">
-            <a:solidFill>
-              <a:srgbClr val="9AA4B0"/>
-            </a:solidFill>
-            <a:prstDash val="solid"/>
-          </a:ln>
-        </p:spPr>
-      </p:sp>
-      <p:sp>
-        <p:nvSpPr>
-          <p:cNvPr id="20" name="Shape 18"/>
-          <p:cNvSpPr/>
-          <p:nvPr/>
-        </p:nvSpPr>
-        <p:spPr>
-          <a:xfrm>
-            <a:off x="4998660" y="1874520"/>
-            <a:ext cx="2088000" cy="2088000"/>
-          </a:xfrm>
-          <a:prstGeom prst="ellipse">
-            <a:avLst/>
-          </a:prstGeom>
-          <a:solidFill>
-            <a:srgbClr val="FFFFFF"/>
-          </a:solidFill>
-          <a:ln w="15875">
-            <a:solidFill>
-              <a:srgbClr val="9AA4B0"/>
-            </a:solidFill>
-            <a:prstDash val="dash"/>
-          </a:ln>
-        </p:spPr>
-      </p:sp>
-      <p:sp>
-        <p:nvSpPr>
-          <p:cNvPr id="21" name="Text 19"/>
-          <p:cNvSpPr txBox="1"/>
-          <p:nvPr/>
-        </p:nvSpPr>
-        <p:spPr>
-          <a:xfrm>
-            <a:off x="4980432" y="4163688"/>
-            <a:ext cx="2124456" cy="292608"/>
-          </a:xfrm>
-          <a:prstGeom prst="rect">
-            <a:avLst/>
-          </a:prstGeom>
-          <a:noFill/>
-          <a:ln/>
-        </p:spPr>
-        <p:txBody>
-          <a:bodyPr wrap="square" lIns="0" tIns="0" rIns="0" bIns="0" rtlCol="0" anchor="t"/>
-          <a:lstStyle/>
-          <a:p>
-            <a:pPr indent="0" marL="0">
-              <a:buNone/>
-            </a:pPr>
-            <a:r>
-              <a:rPr lang="en-US" sz="1000" b="1" dirty="0">
-                <a:solidFill>
-                  <a:srgbClr val="1E2761"/>
-                </a:solidFill>
-                <a:latin typeface="Calibri" pitchFamily="34" charset="0"/>
-                <a:ea typeface="Calibri" pitchFamily="34" charset="-122"/>
-                <a:cs typeface="Calibri" pitchFamily="34" charset="-120"/>
-              </a:rPr>
-              <a:t>Inspiration / how you came up with it:</a:t>
-            </a:r>
-            <a:endParaRPr lang="en-US" sz="1000" dirty="0"/>
-          </a:p>
-        </p:txBody>
-      </p:sp>
-      <p:sp>
-        <p:nvSpPr>
-          <p:cNvPr id="22" name="Shape 20"/>
-          <p:cNvSpPr/>
-          <p:nvPr/>
-        </p:nvSpPr>
-        <p:spPr>
-          <a:xfrm>
-            <a:off x="4980432" y="4547736"/>
-            <a:ext cx="2124456" cy="0"/>
-          </a:xfrm>
-          <a:prstGeom prst="line">
-            <a:avLst/>
-          </a:prstGeom>
-          <a:noFill/>
-          <a:ln w="9525">
-            <a:solidFill>
-              <a:srgbClr val="9AA4B0"/>
-            </a:solidFill>
-            <a:prstDash val="solid"/>
-          </a:ln>
-        </p:spPr>
-      </p:sp>
-      <p:sp>
-        <p:nvSpPr>
           <p:cNvPr id="23" name="Shape 21"/>
           <p:cNvSpPr/>
           <p:nvPr/>
         </p:nvSpPr>
         <p:spPr>
           <a:xfrm>
-            <a:off x="4980432" y="4803768"/>
-            <a:ext cx="2124456" cy="0"/>
-          </a:xfrm>
-          <a:prstGeom prst="line">
-            <a:avLst/>
-          </a:prstGeom>
-          <a:noFill/>
-          <a:ln w="9525">
-            <a:solidFill>
-              <a:srgbClr val="9AA4B0"/>
-            </a:solidFill>
-            <a:prstDash val="solid"/>
-          </a:ln>
-        </p:spPr>
-      </p:sp>
-      <p:sp>
-        <p:nvSpPr>
-          <p:cNvPr id="24" name="Text 22"/>
-          <p:cNvSpPr txBox="1"/>
-          <p:nvPr/>
-        </p:nvSpPr>
-        <p:spPr>
-          <a:xfrm>
-            <a:off x="4980432" y="5004936"/>
-            <a:ext cx="2124456" cy="292608"/>
-          </a:xfrm>
-          <a:prstGeom prst="rect">
-            <a:avLst/>
-          </a:prstGeom>
-          <a:noFill/>
-          <a:ln/>
-        </p:spPr>
-        <p:txBody>
-          <a:bodyPr wrap="square" lIns="0" tIns="0" rIns="0" bIns="0" rtlCol="0" anchor="t"/>
-          <a:lstStyle/>
-          <a:p>
-            <a:pPr indent="0" marL="0">
-              <a:buNone/>
-            </a:pPr>
-            <a:r>
-              <a:rPr lang="en-US" sz="1000" b="1" dirty="0">
-                <a:solidFill>
-                  <a:srgbClr val="1E2761"/>
-                </a:solidFill>
-                <a:latin typeface="Calibri" pitchFamily="34" charset="0"/>
-                <a:ea typeface="Calibri" pitchFamily="34" charset="-122"/>
-                <a:cs typeface="Calibri" pitchFamily="34" charset="-120"/>
-              </a:rPr>
-              <a:t>How it represents your app:</a:t>
-            </a:r>
-            <a:endParaRPr lang="en-US" sz="1000" dirty="0"/>
-          </a:p>
-        </p:txBody>
-      </p:sp>
-      <p:sp>
-        <p:nvSpPr>
-          <p:cNvPr id="25" name="Shape 23"/>
-          <p:cNvSpPr/>
-          <p:nvPr/>
-        </p:nvSpPr>
-        <p:spPr>
-          <a:xfrm>
-            <a:off x="4980432" y="5388984"/>
-            <a:ext cx="2124456" cy="0"/>
-          </a:xfrm>
-          <a:prstGeom prst="line">
-            <a:avLst/>
-          </a:prstGeom>
-          <a:noFill/>
-          <a:ln w="9525">
-            <a:solidFill>
-              <a:srgbClr val="9AA4B0"/>
-            </a:solidFill>
-            <a:prstDash val="solid"/>
-          </a:ln>
-        </p:spPr>
-      </p:sp>
-      <p:sp>
-        <p:nvSpPr>
-          <p:cNvPr id="26" name="Shape 24"/>
-          <p:cNvSpPr/>
-          <p:nvPr/>
-        </p:nvSpPr>
-        <p:spPr>
-          <a:xfrm>
-            <a:off x="4980432" y="5645016"/>
-            <a:ext cx="2124456" cy="0"/>
-          </a:xfrm>
-          <a:prstGeom prst="line">
-            <a:avLst/>
-          </a:prstGeom>
-          <a:noFill/>
-          <a:ln w="9525">
-            <a:solidFill>
-              <a:srgbClr val="9AA4B0"/>
-            </a:solidFill>
-            <a:prstDash val="solid"/>
-          </a:ln>
-        </p:spPr>
-      </p:sp>
-      <p:sp>
-        <p:nvSpPr>
-          <p:cNvPr id="27" name="Shape 25"/>
-          <p:cNvSpPr/>
-          <p:nvPr/>
-        </p:nvSpPr>
-        <p:spPr>
-          <a:xfrm>
-            <a:off x="475428" y="6053328"/>
-            <a:ext cx="2088000" cy="2088000"/>
-          </a:xfrm>
-          <a:prstGeom prst="ellipse">
-            <a:avLst/>
-          </a:prstGeom>
-          <a:solidFill>
-            <a:srgbClr val="FFFFFF"/>
-          </a:solidFill>
-          <a:ln w="15875">
-            <a:solidFill>
-              <a:srgbClr val="9AA4B0"/>
-            </a:solidFill>
-            <a:prstDash val="dash"/>
-          </a:ln>
-        </p:spPr>
-      </p:sp>
-      <p:sp>
-        <p:nvSpPr>
-          <p:cNvPr id="28" name="Text 26"/>
-          <p:cNvSpPr txBox="1"/>
-          <p:nvPr/>
-        </p:nvSpPr>
-        <p:spPr>
-          <a:xfrm>
-            <a:off x="457200" y="8342496"/>
-            <a:ext cx="2124456" cy="292608"/>
-          </a:xfrm>
-          <a:prstGeom prst="rect">
-            <a:avLst/>
-          </a:prstGeom>
-          <a:noFill/>
-          <a:ln/>
-        </p:spPr>
-        <p:txBody>
-          <a:bodyPr wrap="square" lIns="0" tIns="0" rIns="0" bIns="0" rtlCol="0" anchor="t"/>
-          <a:lstStyle/>
-          <a:p>
-            <a:pPr indent="0" marL="0">
-              <a:buNone/>
-            </a:pPr>
-            <a:r>
-              <a:rPr lang="en-US" sz="1000" b="1" dirty="0">
-                <a:solidFill>
-                  <a:srgbClr val="1E2761"/>
-                </a:solidFill>
-                <a:latin typeface="Calibri" pitchFamily="34" charset="0"/>
-                <a:ea typeface="Calibri" pitchFamily="34" charset="-122"/>
-                <a:cs typeface="Calibri" pitchFamily="34" charset="-120"/>
-              </a:rPr>
-              <a:t>Inspiration / how you came up with it:</a:t>
-            </a:r>
-            <a:endParaRPr lang="en-US" sz="1000" dirty="0"/>
-          </a:p>
-        </p:txBody>
-      </p:sp>
-      <p:sp>
-        <p:nvSpPr>
-          <p:cNvPr id="29" name="Shape 27"/>
-          <p:cNvSpPr/>
-          <p:nvPr/>
-        </p:nvSpPr>
-        <p:spPr>
-          <a:xfrm>
-            <a:off x="457200" y="8726544"/>
-            <a:ext cx="2124456" cy="0"/>
-          </a:xfrm>
-          <a:prstGeom prst="line">
-            <a:avLst/>
-          </a:prstGeom>
-          <a:noFill/>
-          <a:ln w="9525">
-            <a:solidFill>
-              <a:srgbClr val="9AA4B0"/>
-            </a:solidFill>
-            <a:prstDash val="solid"/>
-          </a:ln>
-        </p:spPr>
-      </p:sp>
-      <p:sp>
-        <p:nvSpPr>
-          <p:cNvPr id="30" name="Shape 28"/>
-          <p:cNvSpPr/>
-          <p:nvPr/>
-        </p:nvSpPr>
-        <p:spPr>
-          <a:xfrm>
-            <a:off x="457200" y="8982576"/>
-            <a:ext cx="2124456" cy="0"/>
-          </a:xfrm>
-          <a:prstGeom prst="line">
-            <a:avLst/>
-          </a:prstGeom>
-          <a:noFill/>
-          <a:ln w="9525">
-            <a:solidFill>
-              <a:srgbClr val="9AA4B0"/>
-            </a:solidFill>
-            <a:prstDash val="solid"/>
-          </a:ln>
-        </p:spPr>
-      </p:sp>
-      <p:sp>
-        <p:nvSpPr>
-          <p:cNvPr id="31" name="Text 29"/>
-          <p:cNvSpPr txBox="1"/>
-          <p:nvPr/>
-        </p:nvSpPr>
-        <p:spPr>
-          <a:xfrm>
-            <a:off x="457200" y="9183744"/>
-            <a:ext cx="2124456" cy="292608"/>
-          </a:xfrm>
-          <a:prstGeom prst="rect">
-            <a:avLst/>
-          </a:prstGeom>
-          <a:noFill/>
-          <a:ln/>
-        </p:spPr>
-        <p:txBody>
-          <a:bodyPr wrap="square" lIns="0" tIns="0" rIns="0" bIns="0" rtlCol="0" anchor="t"/>
-          <a:lstStyle/>
-          <a:p>
-            <a:pPr indent="0" marL="0">
-              <a:buNone/>
-            </a:pPr>
-            <a:r>
-              <a:rPr lang="en-US" sz="1000" b="1" dirty="0">
-                <a:solidFill>
-                  <a:srgbClr val="1E2761"/>
-                </a:solidFill>
-                <a:latin typeface="Calibri" pitchFamily="34" charset="0"/>
-                <a:ea typeface="Calibri" pitchFamily="34" charset="-122"/>
-                <a:cs typeface="Calibri" pitchFamily="34" charset="-120"/>
-              </a:rPr>
-              <a:t>How it represents your app:</a:t>
-            </a:r>
-            <a:endParaRPr lang="en-US" sz="1000" dirty="0"/>
-          </a:p>
-        </p:txBody>
-      </p:sp>
-      <p:sp>
-        <p:nvSpPr>
-          <p:cNvPr id="32" name="Shape 30"/>
-          <p:cNvSpPr/>
-          <p:nvPr/>
-        </p:nvSpPr>
-        <p:spPr>
-          <a:xfrm>
-            <a:off x="457200" y="9567792"/>
-            <a:ext cx="2124456" cy="0"/>
-          </a:xfrm>
-          <a:prstGeom prst="line">
-            <a:avLst/>
-          </a:prstGeom>
-          <a:noFill/>
-          <a:ln w="9525">
-            <a:solidFill>
-              <a:srgbClr val="9AA4B0"/>
-            </a:solidFill>
-            <a:prstDash val="solid"/>
-          </a:ln>
-        </p:spPr>
-      </p:sp>
-      <p:sp>
-        <p:nvSpPr>
-          <p:cNvPr id="33" name="Shape 31"/>
-          <p:cNvSpPr/>
-          <p:nvPr/>
-        </p:nvSpPr>
-        <p:spPr>
-          <a:xfrm>
-            <a:off x="457200" y="9823824"/>
-            <a:ext cx="2124456" cy="0"/>
-          </a:xfrm>
-          <a:prstGeom prst="line">
-            <a:avLst/>
-          </a:prstGeom>
-          <a:noFill/>
-          <a:ln w="9525">
-            <a:solidFill>
-              <a:srgbClr val="9AA4B0"/>
-            </a:solidFill>
-            <a:prstDash val="solid"/>
-          </a:ln>
-        </p:spPr>
-      </p:sp>
-      <p:sp>
-        <p:nvSpPr>
-          <p:cNvPr id="34" name="Shape 32"/>
-          <p:cNvSpPr/>
-          <p:nvPr/>
-        </p:nvSpPr>
-        <p:spPr>
-          <a:xfrm>
-            <a:off x="2737044" y="6053328"/>
-            <a:ext cx="2088000" cy="2088000"/>
-          </a:xfrm>
-          <a:prstGeom prst="ellipse">
-            <a:avLst/>
-          </a:prstGeom>
-          <a:solidFill>
-            <a:srgbClr val="FFFFFF"/>
-          </a:solidFill>
-          <a:ln w="15875">
-            <a:solidFill>
-              <a:srgbClr val="9AA4B0"/>
-            </a:solidFill>
-            <a:prstDash val="dash"/>
-          </a:ln>
-        </p:spPr>
-      </p:sp>
-      <p:sp>
-        <p:nvSpPr>
-          <p:cNvPr id="35" name="Text 33"/>
-          <p:cNvSpPr txBox="1"/>
-          <p:nvPr/>
-        </p:nvSpPr>
-        <p:spPr>
-          <a:xfrm>
-            <a:off x="2718816" y="8342496"/>
-            <a:ext cx="2124456" cy="292608"/>
-          </a:xfrm>
-          <a:prstGeom prst="rect">
-            <a:avLst/>
-          </a:prstGeom>
-          <a:noFill/>
-          <a:ln/>
-        </p:spPr>
-        <p:txBody>
-          <a:bodyPr wrap="square" lIns="0" tIns="0" rIns="0" bIns="0" rtlCol="0" anchor="t"/>
-          <a:lstStyle/>
-          <a:p>
-            <a:pPr indent="0" marL="0">
-              <a:buNone/>
-            </a:pPr>
-            <a:r>
-              <a:rPr lang="en-US" sz="1000" b="1" dirty="0">
-                <a:solidFill>
-                  <a:srgbClr val="1E2761"/>
-                </a:solidFill>
-                <a:latin typeface="Calibri" pitchFamily="34" charset="0"/>
-                <a:ea typeface="Calibri" pitchFamily="34" charset="-122"/>
-                <a:cs typeface="Calibri" pitchFamily="34" charset="-120"/>
-              </a:rPr>
-              <a:t>Inspiration / how you came up with it:</a:t>
-            </a:r>
-            <a:endParaRPr lang="en-US" sz="1000" dirty="0"/>
-          </a:p>
-        </p:txBody>
-      </p:sp>
-      <p:sp>
-        <p:nvSpPr>
-          <p:cNvPr id="36" name="Shape 34"/>
-          <p:cNvSpPr/>
-          <p:nvPr/>
-        </p:nvSpPr>
-        <p:spPr>
-          <a:xfrm>
-            <a:off x="2718816" y="8726544"/>
-            <a:ext cx="2124456" cy="0"/>
-          </a:xfrm>
-          <a:prstGeom prst="line">
-            <a:avLst/>
-          </a:prstGeom>
-          <a:noFill/>
-          <a:ln w="9525">
-            <a:solidFill>
-              <a:srgbClr val="9AA4B0"/>
-            </a:solidFill>
-            <a:prstDash val="solid"/>
-          </a:ln>
-        </p:spPr>
-      </p:sp>
-      <p:sp>
-        <p:nvSpPr>
-          <p:cNvPr id="37" name="Shape 35"/>
-          <p:cNvSpPr/>
-          <p:nvPr/>
-        </p:nvSpPr>
-        <p:spPr>
-          <a:xfrm>
-            <a:off x="2718816" y="8982576"/>
-            <a:ext cx="2124456" cy="0"/>
-          </a:xfrm>
-          <a:prstGeom prst="line">
-            <a:avLst/>
-          </a:prstGeom>
-          <a:noFill/>
-          <a:ln w="9525">
-            <a:solidFill>
-              <a:srgbClr val="9AA4B0"/>
-            </a:solidFill>
-            <a:prstDash val="solid"/>
-          </a:ln>
-        </p:spPr>
-      </p:sp>
-      <p:sp>
-        <p:nvSpPr>
-          <p:cNvPr id="38" name="Text 36"/>
-          <p:cNvSpPr txBox="1"/>
-          <p:nvPr/>
-        </p:nvSpPr>
-        <p:spPr>
-          <a:xfrm>
-            <a:off x="2718816" y="9183744"/>
-            <a:ext cx="2124456" cy="292608"/>
-          </a:xfrm>
-          <a:prstGeom prst="rect">
-            <a:avLst/>
-          </a:prstGeom>
-          <a:noFill/>
-          <a:ln/>
-        </p:spPr>
-        <p:txBody>
-          <a:bodyPr wrap="square" lIns="0" tIns="0" rIns="0" bIns="0" rtlCol="0" anchor="t"/>
-          <a:lstStyle/>
-          <a:p>
-            <a:pPr indent="0" marL="0">
-              <a:buNone/>
-            </a:pPr>
-            <a:r>
-              <a:rPr lang="en-US" sz="1000" b="1" dirty="0">
-                <a:solidFill>
-                  <a:srgbClr val="1E2761"/>
-                </a:solidFill>
-                <a:latin typeface="Calibri" pitchFamily="34" charset="0"/>
-                <a:ea typeface="Calibri" pitchFamily="34" charset="-122"/>
-                <a:cs typeface="Calibri" pitchFamily="34" charset="-120"/>
-              </a:rPr>
-              <a:t>How it represents your app:</a:t>
-            </a:r>
-            <a:endParaRPr lang="en-US" sz="1000" dirty="0"/>
-          </a:p>
-        </p:txBody>
-      </p:sp>
-      <p:sp>
-        <p:nvSpPr>
-          <p:cNvPr id="39" name="Shape 37"/>
-          <p:cNvSpPr/>
-          <p:nvPr/>
-        </p:nvSpPr>
-        <p:spPr>
-          <a:xfrm>
-            <a:off x="2718816" y="9567792"/>
-            <a:ext cx="2124456" cy="0"/>
-          </a:xfrm>
-          <a:prstGeom prst="line">
-            <a:avLst/>
-          </a:prstGeom>
-          <a:noFill/>
-          <a:ln w="9525">
-            <a:solidFill>
-              <a:srgbClr val="9AA4B0"/>
-            </a:solidFill>
-            <a:prstDash val="solid"/>
-          </a:ln>
-        </p:spPr>
-      </p:sp>
-      <p:sp>
-        <p:nvSpPr>
-          <p:cNvPr id="40" name="Shape 38"/>
-          <p:cNvSpPr/>
-          <p:nvPr/>
-        </p:nvSpPr>
-        <p:spPr>
-          <a:xfrm>
-            <a:off x="2718816" y="9823824"/>
-            <a:ext cx="2124456" cy="0"/>
-          </a:xfrm>
-          <a:prstGeom prst="line">
-            <a:avLst/>
-          </a:prstGeom>
-          <a:noFill/>
-          <a:ln w="9525">
-            <a:solidFill>
-              <a:srgbClr val="9AA4B0"/>
-            </a:solidFill>
-            <a:prstDash val="solid"/>
-          </a:ln>
-        </p:spPr>
-      </p:sp>
-      <p:sp>
-        <p:nvSpPr>
-          <p:cNvPr id="41" name="Shape 39"/>
-          <p:cNvSpPr/>
-          <p:nvPr/>
-        </p:nvSpPr>
-        <p:spPr>
-          <a:xfrm>
-            <a:off x="4998660" y="6053328"/>
-            <a:ext cx="2088000" cy="2088000"/>
-          </a:xfrm>
-          <a:prstGeom prst="ellipse">
-            <a:avLst/>
-          </a:prstGeom>
-          <a:solidFill>
-            <a:srgbClr val="FFFFFF"/>
-          </a:solidFill>
-          <a:ln w="15875">
-            <a:solidFill>
-              <a:srgbClr val="9AA4B0"/>
-            </a:solidFill>
-            <a:prstDash val="dash"/>
-          </a:ln>
-        </p:spPr>
-      </p:sp>
-      <p:sp>
-        <p:nvSpPr>
-          <p:cNvPr id="42" name="Text 40"/>
-          <p:cNvSpPr txBox="1"/>
-          <p:nvPr/>
-        </p:nvSpPr>
-        <p:spPr>
-          <a:xfrm>
-            <a:off x="4980432" y="8342496"/>
-            <a:ext cx="2124456" cy="292608"/>
-          </a:xfrm>
-          <a:prstGeom prst="rect">
-            <a:avLst/>
-          </a:prstGeom>
-          <a:noFill/>
-          <a:ln/>
-        </p:spPr>
-        <p:txBody>
-          <a:bodyPr wrap="square" lIns="0" tIns="0" rIns="0" bIns="0" rtlCol="0" anchor="t"/>
-          <a:lstStyle/>
-          <a:p>
-            <a:pPr indent="0" marL="0">
-              <a:buNone/>
-            </a:pPr>
-            <a:r>
-              <a:rPr lang="en-US" sz="1000" b="1" dirty="0">
-                <a:solidFill>
-                  <a:srgbClr val="1E2761"/>
-                </a:solidFill>
-                <a:latin typeface="Calibri" pitchFamily="34" charset="0"/>
-                <a:ea typeface="Calibri" pitchFamily="34" charset="-122"/>
-                <a:cs typeface="Calibri" pitchFamily="34" charset="-120"/>
-              </a:rPr>
-              <a:t>Inspiration / how you came up with it:</a:t>
-            </a:r>
-            <a:endParaRPr lang="en-US" sz="1000" dirty="0"/>
-          </a:p>
-        </p:txBody>
-      </p:sp>
-      <p:sp>
-        <p:nvSpPr>
-          <p:cNvPr id="43" name="Shape 41"/>
-          <p:cNvSpPr/>
-          <p:nvPr/>
-        </p:nvSpPr>
-        <p:spPr>
-          <a:xfrm>
-            <a:off x="4980432" y="8726544"/>
-            <a:ext cx="2124456" cy="0"/>
-          </a:xfrm>
-          <a:prstGeom prst="line">
-            <a:avLst/>
-          </a:prstGeom>
-          <a:noFill/>
-          <a:ln w="9525">
-            <a:solidFill>
-              <a:srgbClr val="9AA4B0"/>
-            </a:solidFill>
-            <a:prstDash val="solid"/>
-          </a:ln>
-        </p:spPr>
-      </p:sp>
-      <p:sp>
-        <p:nvSpPr>
-          <p:cNvPr id="44" name="Shape 42"/>
-          <p:cNvSpPr/>
-          <p:nvPr/>
-        </p:nvSpPr>
-        <p:spPr>
-          <a:xfrm>
-            <a:off x="4980432" y="8982576"/>
-            <a:ext cx="2124456" cy="0"/>
-          </a:xfrm>
-          <a:prstGeom prst="line">
-            <a:avLst/>
-          </a:prstGeom>
-          <a:noFill/>
-          <a:ln w="9525">
-            <a:solidFill>
-              <a:srgbClr val="9AA4B0"/>
-            </a:solidFill>
-            <a:prstDash val="solid"/>
-          </a:ln>
-        </p:spPr>
-      </p:sp>
-      <p:sp>
-        <p:nvSpPr>
-          <p:cNvPr id="45" name="Text 43"/>
-          <p:cNvSpPr txBox="1"/>
-          <p:nvPr/>
-        </p:nvSpPr>
-        <p:spPr>
-          <a:xfrm>
-            <a:off x="4980432" y="9183744"/>
-            <a:ext cx="2124456" cy="292608"/>
-          </a:xfrm>
-          <a:prstGeom prst="rect">
-            <a:avLst/>
-          </a:prstGeom>
-          <a:noFill/>
-          <a:ln/>
-        </p:spPr>
-        <p:txBody>
-          <a:bodyPr wrap="square" lIns="0" tIns="0" rIns="0" bIns="0" rtlCol="0" anchor="t"/>
-          <a:lstStyle/>
-          <a:p>
-            <a:pPr indent="0" marL="0">
-              <a:buNone/>
-            </a:pPr>
-            <a:r>
-              <a:rPr lang="en-US" sz="1000" b="1" dirty="0">
-                <a:solidFill>
-                  <a:srgbClr val="1E2761"/>
-                </a:solidFill>
-                <a:latin typeface="Calibri" pitchFamily="34" charset="0"/>
-                <a:ea typeface="Calibri" pitchFamily="34" charset="-122"/>
-                <a:cs typeface="Calibri" pitchFamily="34" charset="-120"/>
-              </a:rPr>
-              <a:t>How it represents your app:</a:t>
-            </a:r>
-            <a:endParaRPr lang="en-US" sz="1000" dirty="0"/>
-          </a:p>
-        </p:txBody>
-      </p:sp>
-      <p:sp>
-        <p:nvSpPr>
-          <p:cNvPr id="46" name="Shape 44"/>
-          <p:cNvSpPr/>
-          <p:nvPr/>
-        </p:nvSpPr>
-        <p:spPr>
-          <a:xfrm>
-            <a:off x="4980432" y="9567792"/>
-            <a:ext cx="2124456" cy="0"/>
-          </a:xfrm>
-          <a:prstGeom prst="line">
-            <a:avLst/>
-          </a:prstGeom>
-          <a:noFill/>
-          <a:ln w="9525">
-            <a:solidFill>
-              <a:srgbClr val="9AA4B0"/>
-            </a:solidFill>
-            <a:prstDash val="solid"/>
-          </a:ln>
-        </p:spPr>
-      </p:sp>
-      <p:sp>
-        <p:nvSpPr>
-          <p:cNvPr id="47" name="Shape 45"/>
-          <p:cNvSpPr/>
-          <p:nvPr/>
-        </p:nvSpPr>
-        <p:spPr>
-          <a:xfrm>
-            <a:off x="4980432" y="9823824"/>
-            <a:ext cx="2124456" cy="0"/>
+            <a:off x="457200" y="8702280"/>
+            <a:ext cx="6647688" cy="0"/>
           </a:xfrm>
           <a:prstGeom prst="line">
             <a:avLst/>

</xml_diff>